<commit_message>
feat(parte-7): integrar auditoria de hardware fisico
</commit_message>
<xml_diff>
--- a/classes/parte-7-red-team-y-operaciones-ofensivas/177-red-teaming-fisico/clase-177-presentacion.pptx
+++ b/classes/parte-7-red-team-y-operaciones-ofensivas/177-red-teaming-fisico/clase-177-presentacion.pptx
@@ -20,6 +20,8 @@
     <p:sldId id="268" r:id="rId19"/>
     <p:sldId id="269" r:id="rId20"/>
     <p:sldId id="270" r:id="rId21"/>
+    <p:sldId id="271" r:id="rId22"/>
+    <p:sldId id="272" r:id="rId23"/>
   </p:sldIdLst>
   <p:sldSz cx="9144000" cy="6858000" type="screen4x3"/>
   <p:notesSz cx="6858000" cy="9144000"/>
@@ -3201,7 +3203,7 @@
                   <a:srgbClr val="0B3D2E"/>
                 </a:solidFill>
               </a:rPr>
-              <a:t>✍️ Ejercicios</a:t>
+              <a:t>🔍 Caso integrador — El «adaptador» encontrado en una sala</a:t>
             </a:r>
           </a:p>
         </p:txBody>
@@ -3239,82 +3241,22 @@
                   <a:srgbClr val="22282E"/>
                 </a:solidFill>
               </a:rPr>
-              <a:t>•  Redacta un plan de reconocimiento físico para un edificio ficticio.</a:t>
-            </a:r>
-          </a:p>
-          <a:p>
-            <a:pPr>
-              <a:spcAft>
-                <a:spcPts val="600"/>
-              </a:spcAft>
-            </a:pPr>
-            <a:r>
-              <a:rPr sz="1500">
-                <a:solidFill>
-                  <a:srgbClr val="22282E"/>
-                </a:solidFill>
-              </a:rPr>
-              <a:t>•  Diseña dos pretextos presenciales y evalúa sus riesgos.</a:t>
-            </a:r>
-          </a:p>
-          <a:p>
-            <a:pPr>
-              <a:spcAft>
-                <a:spcPts val="600"/>
-              </a:spcAft>
-            </a:pPr>
-            <a:r>
-              <a:rPr sz="1500">
-                <a:solidFill>
-                  <a:srgbClr val="22282E"/>
-                </a:solidFill>
-              </a:rPr>
-              <a:t>•  Explica el clonado RFID y sus límites según la frecuencia.</a:t>
-            </a:r>
-          </a:p>
-          <a:p>
-            <a:pPr>
-              <a:spcAft>
-                <a:spcPts val="600"/>
-              </a:spcAft>
-            </a:pPr>
-            <a:r>
-              <a:rPr sz="1500">
-                <a:solidFill>
-                  <a:srgbClr val="22282E"/>
-                </a:solidFill>
-              </a:rPr>
-              <a:t>•  Programa un payload HID que lance una shell en tu lab.</a:t>
-            </a:r>
-          </a:p>
-          <a:p>
-            <a:pPr>
-              <a:spcAft>
-                <a:spcPts val="600"/>
-              </a:spcAft>
-            </a:pPr>
-            <a:r>
-              <a:rPr sz="1500">
-                <a:solidFill>
-                  <a:srgbClr val="22282E"/>
-                </a:solidFill>
-              </a:rPr>
-              <a:t>•  Configura un dropbox que llame a casa por C2.</a:t>
-            </a:r>
-          </a:p>
-          <a:p>
-            <a:pPr>
-              <a:spcAft>
-                <a:spcPts val="600"/>
-              </a:spcAft>
-            </a:pPr>
-            <a:r>
-              <a:rPr sz="1500">
-                <a:solidFill>
-                  <a:srgbClr val="22282E"/>
-                </a:solidFill>
-              </a:rPr>
-              <a:t>•  Escribe una plantilla de carta de autorización con 8 campos.</a:t>
+              <a:t>•  Un equipo reporta un adaptador USB-Ethernet conectado detrás de un puesto. A los 18 segundos aparece una interfaz RNDIS; el host obtiene otra ruta por DHCP; un sensor registra una consulta DNS…</a:t>
+            </a:r>
+          </a:p>
+          <a:p>
+            <a:pPr>
+              <a:spcAft>
+                <a:spcPts val="600"/>
+              </a:spcAft>
+            </a:pPr>
+            <a:r>
+              <a:rPr sz="1500">
+                <a:solidFill>
+                  <a:srgbClr val="22282E"/>
+                </a:solidFill>
+              </a:rPr>
+              <a:t>•  La respuesta correcta no es etiquetarlo inmediatamente como Bash Bunny o LAN Turtle. El analista fotografía ubicación y conexiones, registra hora y custodio, aísla el host de acuerdo con el playbook…</a:t>
             </a:r>
           </a:p>
         </p:txBody>
@@ -3365,7 +3307,7 @@
                   <a:srgbClr val="0B3D2E"/>
                 </a:solidFill>
               </a:rPr>
-              <a:t>📝 Reto verificable</a:t>
+              <a:t>✍️ Ejercicios</a:t>
             </a:r>
           </a:p>
         </p:txBody>
@@ -3403,22 +3345,82 @@
                   <a:srgbClr val="22282E"/>
                 </a:solidFill>
               </a:rPr>
-              <a:t>•  Prepara un kit de operación física (teórico + práctico en tu entorno): plan de recon, pretexto, un HID que lanza C2 en tu equipo, un dropbox que establece C2 en tu lab y una carta de autorización.</a:t>
-            </a:r>
-          </a:p>
-          <a:p>
-            <a:pPr>
-              <a:spcAft>
-                <a:spcPts val="600"/>
-              </a:spcAft>
-            </a:pPr>
-            <a:r>
-              <a:rPr sz="1500">
-                <a:solidFill>
-                  <a:srgbClr val="22282E"/>
-                </a:solidFill>
-              </a:rPr>
-              <a:t>•  Criterio de aceptación: demuestras el HID abriendo una sesión C2 en tu propia máquina y el dropbox estableciendo C2 en tu lab; entregas el plan de recon, el pretexto y la carta de autorización…</a:t>
+              <a:t>•  Explica por qué bloquear almacenamiento no detiene necesariamente HID ni Ethernet USB.</a:t>
+            </a:r>
+          </a:p>
+          <a:p>
+            <a:pPr>
+              <a:spcAft>
+                <a:spcPts val="600"/>
+              </a:spcAft>
+            </a:pPr>
+            <a:r>
+              <a:rPr sz="1500">
+                <a:solidFill>
+                  <a:srgbClr val="22282E"/>
+                </a:solidFill>
+              </a:rPr>
+              <a:t>•  Compara Rubber Ducky, Bash Bunny, O.MG Cable, una placa USB nativa y Cynthion por función, administración y evidencia.</a:t>
+            </a:r>
+          </a:p>
+          <a:p>
+            <a:pPr>
+              <a:spcAft>
+                <a:spcPts val="600"/>
+              </a:spcAft>
+            </a:pPr>
+            <a:r>
+              <a:rPr sz="1500">
+                <a:solidFill>
+                  <a:srgbClr val="22282E"/>
+                </a:solidFill>
+              </a:rPr>
+              <a:t>•  Diseña una política de compra, préstamo, actualización y borrado para accesorios de auditoría.</a:t>
+            </a:r>
+          </a:p>
+          <a:p>
+            <a:pPr>
+              <a:spcAft>
+                <a:spcPts val="600"/>
+              </a:spcAft>
+            </a:pPr>
+            <a:r>
+              <a:rPr sz="1500">
+                <a:solidFill>
+                  <a:srgbClr val="22282E"/>
+                </a:solidFill>
+              </a:rPr>
+              <a:t>•  Propón tres fuentes para investigar una nueva interfaz USB y especifica un falso positivo y un falso negativo por fuente.</a:t>
+            </a:r>
+          </a:p>
+          <a:p>
+            <a:pPr>
+              <a:spcAft>
+                <a:spcPts val="600"/>
+              </a:spcAft>
+            </a:pPr>
+            <a:r>
+              <a:rPr sz="1500">
+                <a:solidFill>
+                  <a:srgbClr val="22282E"/>
+                </a:solidFill>
+              </a:rPr>
+              <a:t>•  Modela una prueba de Packet Squirrel en modo puente sin Internet y define cómo demostrar que fue retirado.</a:t>
+            </a:r>
+          </a:p>
+          <a:p>
+            <a:pPr>
+              <a:spcAft>
+                <a:spcPts val="600"/>
+              </a:spcAft>
+            </a:pPr>
+            <a:r>
+              <a:rPr sz="1500">
+                <a:solidFill>
+                  <a:srgbClr val="22282E"/>
+                </a:solidFill>
+              </a:rPr>
+              <a:t>•  Redacta una decisión de contención que preserve evidencia sin dejar el endpoint conectado a una red dudosa.</a:t>
             </a:r>
           </a:p>
         </p:txBody>
@@ -3469,7 +3471,7 @@
                   <a:srgbClr val="0B3D2E"/>
                 </a:solidFill>
               </a:rPr>
-              <a:t>⚠️ Errores comunes</a:t>
+              <a:t>📝 Reto verificable</a:t>
             </a:r>
           </a:p>
         </p:txBody>
@@ -3507,67 +3509,22 @@
                   <a:srgbClr val="22282E"/>
                 </a:solidFill>
               </a:rPr>
-              <a:t>•  Sin carta de autorización — Riesgo legal enorme; nunca operes sin ella firmada</a:t>
-            </a:r>
-          </a:p>
-          <a:p>
-            <a:pPr>
-              <a:spcAft>
-                <a:spcPts val="600"/>
-              </a:spcAft>
-            </a:pPr>
-            <a:r>
-              <a:rPr sz="1500">
-                <a:solidFill>
-                  <a:srgbClr val="22282E"/>
-                </a:solidFill>
-              </a:rPr>
-              <a:t>•  El clonado RFID no lee — Frecuencia equivocada (125 kHz vs 13.56 MHz); identifica el tipo de tarjeta</a:t>
-            </a:r>
-          </a:p>
-          <a:p>
-            <a:pPr>
-              <a:spcAft>
-                <a:spcPts val="600"/>
-              </a:spcAft>
-            </a:pPr>
-            <a:r>
-              <a:rPr sz="1500">
-                <a:solidFill>
-                  <a:srgbClr val="22282E"/>
-                </a:solidFill>
-              </a:rPr>
-              <a:t>•  HID no ejecuta — Layout de teclado distinto; ajusta el mapeo de teclas</a:t>
-            </a:r>
-          </a:p>
-          <a:p>
-            <a:pPr>
-              <a:spcAft>
-                <a:spcPts val="600"/>
-              </a:spcAft>
-            </a:pPr>
-            <a:r>
-              <a:rPr sz="1500">
-                <a:solidFill>
-                  <a:srgbClr val="22282E"/>
-                </a:solidFill>
-              </a:rPr>
-              <a:t>•  Dropbox no llama a casa — Egress filtrado; usa un canal permitido (HTTPS por proxy)</a:t>
-            </a:r>
-          </a:p>
-          <a:p>
-            <a:pPr>
-              <a:spcAft>
-                <a:spcPts val="600"/>
-              </a:spcAft>
-            </a:pPr>
-            <a:r>
-              <a:rPr sz="1500">
-                <a:solidFill>
-                  <a:srgbClr val="22282E"/>
-                </a:solidFill>
-              </a:rPr>
-              <a:t>•  Pretexto poco creíble — Falta recon; adapta props y discurso al entorno real</a:t>
+              <a:t>•  Entrega un expediente de prueba con RoE, inventario antes/después, payload HID inocuo, línea de tiempo, política defensiva ensayada, evidencia del resultado, restauración y una conclusión graduada.</a:t>
+            </a:r>
+          </a:p>
+          <a:p>
+            <a:pPr>
+              <a:spcAft>
+                <a:spcPts val="600"/>
+              </a:spcAft>
+            </a:pPr>
+            <a:r>
+              <a:rPr sz="1500">
+                <a:solidFill>
+                  <a:srgbClr val="22282E"/>
+                </a:solidFill>
+              </a:rPr>
+              <a:t>•  Criterio de aceptación: la prueba no abre shell ni red; identifica todas las interfaces; distingue conexión, conducta y atribución; demuestra un control que bloquea el dispositivo de prueba sin…</a:t>
             </a:r>
           </a:p>
         </p:txBody>
@@ -3618,7 +3575,7 @@
                   <a:srgbClr val="0B3D2E"/>
                 </a:solidFill>
               </a:rPr>
-              <a:t>❓ Preguntas frecuentes</a:t>
+              <a:t>📊 Matriz de cobertura de la ampliación</a:t>
             </a:r>
           </a:p>
         </p:txBody>
@@ -3656,82 +3613,97 @@
                   <a:srgbClr val="22282E"/>
                 </a:solidFill>
               </a:rPr>
-              <a:t>•  ❓ ¿El red teaming físico es legal?</a:t>
-            </a:r>
-          </a:p>
-          <a:p>
-            <a:pPr>
-              <a:spcAft>
-                <a:spcPts val="600"/>
-              </a:spcAft>
-            </a:pPr>
-            <a:r>
-              <a:rPr sz="1500">
-                <a:solidFill>
-                  <a:srgbClr val="22282E"/>
-                </a:solidFill>
-              </a:rPr>
-              <a:t>•  Solo con autorización escrita del propietario y dentro de RoE claras. Sin eso, es allanamiento. La carta de autorización es innegociable.</a:t>
-            </a:r>
-          </a:p>
-          <a:p>
-            <a:pPr>
-              <a:spcAft>
-                <a:spcPts val="600"/>
-              </a:spcAft>
-            </a:pPr>
-            <a:r>
-              <a:rPr sz="1500">
-                <a:solidFill>
-                  <a:srgbClr val="22282E"/>
-                </a:solidFill>
-              </a:rPr>
-              <a:t>•  ❓ ¿Por qué combinar físico y red?</a:t>
-            </a:r>
-          </a:p>
-          <a:p>
-            <a:pPr>
-              <a:spcAft>
-                <a:spcPts val="600"/>
-              </a:spcAft>
-            </a:pPr>
-            <a:r>
-              <a:rPr sz="1500">
-                <a:solidFill>
-                  <a:srgbClr val="22282E"/>
-                </a:solidFill>
-              </a:rPr>
-              <a:t>•  Porque un atacante real no respeta la frontera: un dropbox o un badge clonado puede saltarse todo el perímetro de red. El ejercicio evalúa esa realidad.</a:t>
-            </a:r>
-          </a:p>
-          <a:p>
-            <a:pPr>
-              <a:spcAft>
-                <a:spcPts val="600"/>
-              </a:spcAft>
-            </a:pPr>
-            <a:r>
-              <a:rPr sz="1500">
-                <a:solidFill>
-                  <a:srgbClr val="22282E"/>
-                </a:solidFill>
-              </a:rPr>
-              <a:t>•  ❓ ¿Puedo practicar lockpicking?</a:t>
-            </a:r>
-          </a:p>
-          <a:p>
-            <a:pPr>
-              <a:spcAft>
-                <a:spcPts val="600"/>
-              </a:spcAft>
-            </a:pPr>
-            <a:r>
-              <a:rPr sz="1500">
-                <a:solidFill>
-                  <a:srgbClr val="22282E"/>
-                </a:solidFill>
-              </a:rPr>
-              <a:t>•  Solo en cerraduras propias y donde sea legal poseer las herramientas. Varían las leyes por país; infórmate antes.</a:t>
+              <a:t>•  La columna inicial conserva el diagnóstico realizado el 6 de octubre de 2026 antes de esta revisión. «Mencionado» no significa enseñado.</a:t>
+            </a:r>
+          </a:p>
+          <a:p>
+            <a:pPr>
+              <a:spcAft>
+                <a:spcPts val="600"/>
+              </a:spcAft>
+            </a:pPr>
+            <a:r>
+              <a:rPr sz="1500">
+                <a:solidFill>
+                  <a:srgbClr val="22282E"/>
+                </a:solidFill>
+              </a:rPr>
+              <a:t>•  El video y las marcas de tiempo aportados se usaron como mapa temático, pero el video no pudo inspeccionarse de forma reproducible en este entorno. Por eso ninguna afirmación técnica depende de él…</a:t>
+            </a:r>
+          </a:p>
+          <a:p>
+            <a:pPr>
+              <a:spcAft>
+                <a:spcPts val="600"/>
+              </a:spcAft>
+            </a:pPr>
+            <a:r>
+              <a:rPr sz="1500">
+                <a:solidFill>
+                  <a:srgbClr val="22282E"/>
+                </a:solidFill>
+              </a:rPr>
+              <a:t>•  Familia o equipo — Cobertura inicial y evidencia</a:t>
+            </a:r>
+          </a:p>
+          <a:p>
+            <a:pPr>
+              <a:spcAft>
+                <a:spcPts val="600"/>
+              </a:spcAft>
+            </a:pPr>
+            <a:r>
+              <a:rPr sz="1500">
+                <a:solidFill>
+                  <a:srgbClr val="22282E"/>
+                </a:solidFill>
+              </a:rPr>
+              <a:t>•  O.MG Cable — Mencionado en herramientas de esta clase; sin modelo, administración ni defensa</a:t>
+            </a:r>
+          </a:p>
+          <a:p>
+            <a:pPr>
+              <a:spcAft>
+                <a:spcPts val="600"/>
+              </a:spcAft>
+            </a:pPr>
+            <a:r>
+              <a:rPr sz="1500">
+                <a:solidFill>
+                  <a:srgbClr val="22282E"/>
+                </a:solidFill>
+              </a:rPr>
+              <a:t>•  USB Rubber Ducky — Parcialmente desarrollado aquí; la práctica anterior abría C2 y no evaluaba telemetría</a:t>
+            </a:r>
+          </a:p>
+          <a:p>
+            <a:pPr>
+              <a:spcAft>
+                <a:spcPts val="600"/>
+              </a:spcAft>
+            </a:pPr>
+            <a:r>
+              <a:rPr sz="1500">
+                <a:solidFill>
+                  <a:srgbClr val="22282E"/>
+                </a:solidFill>
+              </a:rPr>
+              <a:t>•  Bash Bunny — Ausente</a:t>
+            </a:r>
+          </a:p>
+          <a:p>
+            <a:pPr>
+              <a:spcAft>
+                <a:spcPts val="600"/>
+              </a:spcAft>
+            </a:pPr>
+            <a:r>
+              <a:rPr sz="1500">
+                <a:solidFill>
+                  <a:srgbClr val="22282E"/>
+                </a:solidFill>
+              </a:rPr>
+              <a:t>•  WiFi Pineapple — Ausente en la Clase 272</a:t>
             </a:r>
           </a:p>
         </p:txBody>
@@ -3782,7 +3754,7 @@
                   <a:srgbClr val="0B3D2E"/>
                 </a:solidFill>
               </a:rPr>
-              <a:t>🔗 Referencias</a:t>
+              <a:t>⚠️ Errores comunes</a:t>
             </a:r>
           </a:p>
         </p:txBody>
@@ -3820,67 +3792,97 @@
                   <a:srgbClr val="22282E"/>
                 </a:solidFill>
               </a:rPr>
-              <a:t>•  NIST — Technical Guide to Information Security Testing and Assessment, SP 800-115. &lt;https://doi.org/10.6028/NIST.SP.800-115&gt; — base para autorización, planificación segura, evidencia y reglas de…</a:t>
-            </a:r>
-          </a:p>
-          <a:p>
-            <a:pPr>
-              <a:spcAft>
-                <a:spcPts val="600"/>
-              </a:spcAft>
-            </a:pPr>
-            <a:r>
-              <a:rPr sz="1500">
-                <a:solidFill>
-                  <a:srgbClr val="22282E"/>
-                </a:solidFill>
-              </a:rPr>
-              <a:t>•  NIST — Security and Privacy Controls for Information Systems and Organizations, SP 800-53 Rev. 5, familia PE. &lt;https://doi.org/10.6028/NIST.SP.800-53r5&gt; — sustenta defensa física en profundidad…</a:t>
-            </a:r>
-          </a:p>
-          <a:p>
-            <a:pPr>
-              <a:spcAft>
-                <a:spcPts val="600"/>
-              </a:spcAft>
-            </a:pPr>
-            <a:r>
-              <a:rPr sz="1500">
-                <a:solidFill>
-                  <a:srgbClr val="22282E"/>
-                </a:solidFill>
-              </a:rPr>
-              <a:t>•  MITRE ATT&amp;CK — Hardware Additions (T1200). &lt;https://attack.mitre.org/techniques/T1200/&gt; — clasificación del riesgo de añadir dispositivos y sus mitigaciones.</a:t>
-            </a:r>
-          </a:p>
-          <a:p>
-            <a:pPr>
-              <a:spcAft>
-                <a:spcPts val="600"/>
-              </a:spcAft>
-            </a:pPr>
-            <a:r>
-              <a:rPr sz="1500">
-                <a:solidFill>
-                  <a:srgbClr val="22282E"/>
-                </a:solidFill>
-              </a:rPr>
-              <a:t>•  TOOOL — recursos educativos y código ético. &lt;https://toool.us/&gt; — referencia de seguridad y práctica responsable de cerraduras.</a:t>
-            </a:r>
-          </a:p>
-          <a:p>
-            <a:pPr>
-              <a:spcAft>
-                <a:spcPts val="600"/>
-              </a:spcAft>
-            </a:pPr>
-            <a:r>
-              <a:rPr sz="1500">
-                <a:solidFill>
-                  <a:srgbClr val="22282E"/>
-                </a:solidFill>
-              </a:rPr>
-              <a:t>•  Proxmark3. &lt;https://github.com/RfidResearchGroup/proxmark3&gt; y Hak5 USB Rubber Ducky. &lt;https://docs.hak5.org/hak5-usb-rubber-ducky/&gt; — documentación de los dispositivos del laboratorio, sin asumir que…</a:t>
+              <a:t>•  Error — Por qué falla</a:t>
+            </a:r>
+          </a:p>
+          <a:p>
+            <a:pPr>
+              <a:spcAft>
+                <a:spcPts val="600"/>
+              </a:spcAft>
+            </a:pPr>
+            <a:r>
+              <a:rPr sz="1500">
+                <a:solidFill>
+                  <a:srgbClr val="22282E"/>
+                </a:solidFill>
+              </a:rPr>
+              <a:t>•  «Bloqueamos pendrives, por tanto bloqueamos USB malicioso» — almacenamiento es solo una interfaz</a:t>
+            </a:r>
+          </a:p>
+          <a:p>
+            <a:pPr>
+              <a:spcAft>
+                <a:spcPts val="600"/>
+              </a:spcAft>
+            </a:pPr>
+            <a:r>
+              <a:rPr sz="1500">
+                <a:solidFill>
+                  <a:srgbClr val="22282E"/>
+                </a:solidFill>
+              </a:rPr>
+              <a:t>•  «El VID/PID demuestra que es un producto X» — los descriptores pueden modificarse</a:t>
+            </a:r>
+          </a:p>
+          <a:p>
+            <a:pPr>
+              <a:spcAft>
+                <a:spcPts val="600"/>
+              </a:spcAft>
+            </a:pPr>
+            <a:r>
+              <a:rPr sz="1500">
+                <a:solidFill>
+                  <a:srgbClr val="22282E"/>
+                </a:solidFill>
+              </a:rPr>
+              <a:t>•  Ejecutar una shell para probar HID — amplía impacto sin necesidad</a:t>
+            </a:r>
+          </a:p>
+          <a:p>
+            <a:pPr>
+              <a:spcAft>
+                <a:spcPts val="600"/>
+              </a:spcAft>
+            </a:pPr>
+            <a:r>
+              <a:rPr sz="1500">
+                <a:solidFill>
+                  <a:srgbClr val="22282E"/>
+                </a:solidFill>
+              </a:rPr>
+              <a:t>•  Confiar en el aspecto del cable — el implante conserva función aparente</a:t>
+            </a:r>
+          </a:p>
+          <a:p>
+            <a:pPr>
+              <a:spcAft>
+                <a:spcPts val="600"/>
+              </a:spcAft>
+            </a:pPr>
+            <a:r>
+              <a:rPr sz="1500">
+                <a:solidFill>
+                  <a:srgbClr val="22282E"/>
+                </a:solidFill>
+              </a:rPr>
+              <a:t>•  Conectar evidencia a otro portátil — altera estado y puede ejecutar funciones</a:t>
+            </a:r>
+          </a:p>
+          <a:p>
+            <a:pPr>
+              <a:spcAft>
+                <a:spcPts val="600"/>
+              </a:spcAft>
+            </a:pPr>
+            <a:r>
+              <a:rPr sz="1500">
+                <a:solidFill>
+                  <a:srgbClr val="22282E"/>
+                </a:solidFill>
+              </a:rPr>
+              <a:t>•  Aplicar una política de bloqueo sin recuperación — puede dejar sin teclado o dock</a:t>
             </a:r>
           </a:p>
         </p:txBody>
@@ -3911,6 +3913,319 @@
         </p:nvSpPr>
         <p:spPr>
           <a:xfrm>
+            <a:off x="457200" y="320040"/>
+            <a:ext cx="8229600" cy="822960"/>
+          </a:xfrm>
+          <a:prstGeom prst="rect">
+            <a:avLst/>
+          </a:prstGeom>
+          <a:noFill/>
+        </p:spPr>
+        <p:txBody>
+          <a:bodyPr wrap="square">
+            <a:spAutoFit/>
+          </a:bodyPr>
+          <a:lstStyle/>
+          <a:p>
+            <a:r>
+              <a:rPr sz="2600" b="1">
+                <a:solidFill>
+                  <a:srgbClr val="0B3D2E"/>
+                </a:solidFill>
+              </a:rPr>
+              <a:t>❓ Preguntas frecuentes</a:t>
+            </a:r>
+          </a:p>
+        </p:txBody>
+      </p:sp>
+      <p:sp>
+        <p:nvSpPr>
+          <p:cNvPr id="3" name="TextBox 2"/>
+          <p:cNvSpPr txBox="1"/>
+          <p:nvPr/>
+        </p:nvSpPr>
+        <p:spPr>
+          <a:xfrm>
+            <a:off x="457200" y="1280160"/>
+            <a:ext cx="8229600" cy="4937760"/>
+          </a:xfrm>
+          <a:prstGeom prst="rect">
+            <a:avLst/>
+          </a:prstGeom>
+          <a:noFill/>
+        </p:spPr>
+        <p:txBody>
+          <a:bodyPr wrap="square">
+            <a:spAutoFit/>
+          </a:bodyPr>
+          <a:lstStyle/>
+          <a:p>
+            <a:pPr>
+              <a:spcAft>
+                <a:spcPts val="600"/>
+              </a:spcAft>
+            </a:pPr>
+            <a:r>
+              <a:rPr sz="1500">
+                <a:solidFill>
+                  <a:srgbClr val="22282E"/>
+                </a:solidFill>
+              </a:rPr>
+              <a:t>•  ¿Un dispositivo HID puede escribir si la pantalla está bloqueada? Puede enumerar, pero la pantalla bloqueada cambia el destino y el efecto de las teclas. La prueba debe observarlo; no asumir…</a:t>
+            </a:r>
+          </a:p>
+          <a:p>
+            <a:pPr>
+              <a:spcAft>
+                <a:spcPts val="600"/>
+              </a:spcAft>
+            </a:pPr>
+            <a:r>
+              <a:rPr sz="1500">
+                <a:solidFill>
+                  <a:srgbClr val="22282E"/>
+                </a:solidFill>
+              </a:rPr>
+              <a:t>•  ¿Un «USB data blocker» es una defensa completa? No. Es útil para una necesidad concreta de carga sin datos. No sustituye inventario, políticas de interfaz ni controles cuando sí hace falta transferir…</a:t>
+            </a:r>
+          </a:p>
+          <a:p>
+            <a:pPr>
+              <a:spcAft>
+                <a:spcPts val="600"/>
+              </a:spcAft>
+            </a:pPr>
+            <a:r>
+              <a:rPr sz="1500">
+                <a:solidFill>
+                  <a:srgbClr val="22282E"/>
+                </a:solidFill>
+              </a:rPr>
+              <a:t>•  ¿Se puede saber la marca por los logs? A veces aparece un nombre o VID/PID consistente, pero son datos declarados. Se informa como indicio, no como atribución concluyente.</a:t>
+            </a:r>
+          </a:p>
+          <a:p>
+            <a:pPr>
+              <a:spcAft>
+                <a:spcPts val="600"/>
+              </a:spcAft>
+            </a:pPr>
+            <a:r>
+              <a:rPr sz="1500">
+                <a:solidFill>
+                  <a:srgbClr val="22282E"/>
+                </a:solidFill>
+              </a:rPr>
+              <a:t>•  ¿Qué significa controlar el equipo? Administrarlo incluye firmware, configuración, acceso, respaldo y borrado. Controlar su riesgo significa impedir o detectar efectos no autorizados sobre el…</a:t>
+            </a:r>
+          </a:p>
+        </p:txBody>
+      </p:sp>
+    </p:spTree>
+  </p:cSld>
+  <p:clrMapOvr>
+    <a:masterClrMapping/>
+  </p:clrMapOvr>
+</p:sld>
+</file>
+
+<file path=ppt/slides/slide16.xml><?xml version="1.0" encoding="utf-8"?>
+<p:sld xmlns:a="http://schemas.openxmlformats.org/drawingml/2006/main" xmlns:p="http://schemas.openxmlformats.org/presentationml/2006/main" xmlns:r="http://schemas.openxmlformats.org/officeDocument/2006/relationships">
+  <p:cSld>
+    <p:spTree>
+      <p:nvGrpSpPr>
+        <p:cNvPr id="1" name=""/>
+        <p:cNvGrpSpPr/>
+        <p:nvPr/>
+      </p:nvGrpSpPr>
+      <p:grpSpPr/>
+      <p:sp>
+        <p:nvSpPr>
+          <p:cNvPr id="2" name="TextBox 1"/>
+          <p:cNvSpPr txBox="1"/>
+          <p:nvPr/>
+        </p:nvSpPr>
+        <p:spPr>
+          <a:xfrm>
+            <a:off x="457200" y="320040"/>
+            <a:ext cx="8229600" cy="822960"/>
+          </a:xfrm>
+          <a:prstGeom prst="rect">
+            <a:avLst/>
+          </a:prstGeom>
+          <a:noFill/>
+        </p:spPr>
+        <p:txBody>
+          <a:bodyPr wrap="square">
+            <a:spAutoFit/>
+          </a:bodyPr>
+          <a:lstStyle/>
+          <a:p>
+            <a:r>
+              <a:rPr sz="2600" b="1">
+                <a:solidFill>
+                  <a:srgbClr val="0B3D2E"/>
+                </a:solidFill>
+              </a:rPr>
+              <a:t>🔗 Referencias verificables y alcance</a:t>
+            </a:r>
+          </a:p>
+        </p:txBody>
+      </p:sp>
+      <p:sp>
+        <p:nvSpPr>
+          <p:cNvPr id="3" name="TextBox 2"/>
+          <p:cNvSpPr txBox="1"/>
+          <p:nvPr/>
+        </p:nvSpPr>
+        <p:spPr>
+          <a:xfrm>
+            <a:off x="457200" y="1280160"/>
+            <a:ext cx="8229600" cy="4937760"/>
+          </a:xfrm>
+          <a:prstGeom prst="rect">
+            <a:avLst/>
+          </a:prstGeom>
+          <a:noFill/>
+        </p:spPr>
+        <p:txBody>
+          <a:bodyPr wrap="square">
+            <a:spAutoFit/>
+          </a:bodyPr>
+          <a:lstStyle/>
+          <a:p>
+            <a:pPr>
+              <a:spcAft>
+                <a:spcPts val="600"/>
+              </a:spcAft>
+            </a:pPr>
+            <a:r>
+              <a:rPr sz="1500">
+                <a:solidFill>
+                  <a:srgbClr val="22282E"/>
+                </a:solidFill>
+              </a:rPr>
+              <a:t>•  NIST, SP 800-115 — Technical Guide to Information Security Testing and Assessment — planificación, reglas, ejecución segura y reporte.</a:t>
+            </a:r>
+          </a:p>
+          <a:p>
+            <a:pPr>
+              <a:spcAft>
+                <a:spcPts val="600"/>
+              </a:spcAft>
+            </a:pPr>
+            <a:r>
+              <a:rPr sz="1500">
+                <a:solidFill>
+                  <a:srgbClr val="22282E"/>
+                </a:solidFill>
+              </a:rPr>
+              <a:t>•  NIST, SP 800-53 Rev. 5, familia PE — acceso físico, visitantes y monitoreo como defensa en profundidad.</a:t>
+            </a:r>
+          </a:p>
+          <a:p>
+            <a:pPr>
+              <a:spcAft>
+                <a:spcPts val="600"/>
+              </a:spcAft>
+            </a:pPr>
+            <a:r>
+              <a:rPr sz="1500">
+                <a:solidFill>
+                  <a:srgbClr val="22282E"/>
+                </a:solidFill>
+              </a:rPr>
+              <a:t>•  MITRE ATT&amp;CK, T1200 — Hardware Additions — modela la adición de hardware; no identifica un producto concreto.</a:t>
+            </a:r>
+          </a:p>
+          <a:p>
+            <a:pPr>
+              <a:spcAft>
+                <a:spcPts val="600"/>
+              </a:spcAft>
+            </a:pPr>
+            <a:r>
+              <a:rPr sz="1500">
+                <a:solidFill>
+                  <a:srgbClr val="22282E"/>
+                </a:solidFill>
+              </a:rPr>
+              <a:t>•  Hak5, DuckyScript Quick Reference — modos HID/storage, sintaxis y diferencias por versión/dispositivo.</a:t>
+            </a:r>
+          </a:p>
+          <a:p>
+            <a:pPr>
+              <a:spcAft>
+                <a:spcPts val="600"/>
+              </a:spcAft>
+            </a:pPr>
+            <a:r>
+              <a:rPr sz="1500">
+                <a:solidFill>
+                  <a:srgbClr val="22282E"/>
+                </a:solidFill>
+              </a:rPr>
+              <a:t>•  Hak5, Bash Bunny ATTACKMODE — interfaces serie, almacenamiento, HID y Ethernet, incluidas restricciones de combinación.</a:t>
+            </a:r>
+          </a:p>
+          <a:p>
+            <a:pPr>
+              <a:spcAft>
+                <a:spcPts val="600"/>
+              </a:spcAft>
+            </a:pPr>
+            <a:r>
+              <a:rPr sz="1500">
+                <a:solidFill>
+                  <a:srgbClr val="22282E"/>
+                </a:solidFill>
+              </a:rPr>
+              <a:t>•  Hak5, O.MG Cable y comparación de variantes — capacidades declaradas por generación/variante; no se generalizan a todos los cables.</a:t>
+            </a:r>
+          </a:p>
+          <a:p>
+            <a:pPr>
+              <a:spcAft>
+                <a:spcPts val="600"/>
+              </a:spcAft>
+            </a:pPr>
+            <a:r>
+              <a:rPr sz="1500">
+                <a:solidFill>
+                  <a:srgbClr val="22282E"/>
+                </a:solidFill>
+              </a:rPr>
+              <a:t>•  Great Scott Gadgets, Cynthion — analizador USB 2.0, Packetry, LUNA y Facedancer.</a:t>
+            </a:r>
+          </a:p>
+        </p:txBody>
+      </p:sp>
+    </p:spTree>
+  </p:cSld>
+  <p:clrMapOvr>
+    <a:masterClrMapping/>
+  </p:clrMapOvr>
+</p:sld>
+</file>
+
+<file path=ppt/slides/slide17.xml><?xml version="1.0" encoding="utf-8"?>
+<p:sld xmlns:a="http://schemas.openxmlformats.org/drawingml/2006/main" xmlns:p="http://schemas.openxmlformats.org/presentationml/2006/main" xmlns:r="http://schemas.openxmlformats.org/officeDocument/2006/relationships">
+  <p:cSld>
+    <p:spTree>
+      <p:nvGrpSpPr>
+        <p:cNvPr id="1" name=""/>
+        <p:cNvGrpSpPr/>
+        <p:nvPr/>
+      </p:nvGrpSpPr>
+      <p:grpSpPr/>
+      <p:sp>
+        <p:nvSpPr>
+          <p:cNvPr id="2" name="TextBox 1"/>
+          <p:cNvSpPr txBox="1"/>
+          <p:nvPr/>
+        </p:nvSpPr>
+        <p:spPr>
+          <a:xfrm>
             <a:off x="457200" y="274320"/>
             <a:ext cx="8229600" cy="640080"/>
           </a:xfrm>
@@ -3938,7 +4253,7 @@
       </p:sp>
       <p:pic>
         <p:nvPicPr>
-          <p:cNvPr id="3" name="Picture 2" descr="096dfbf77107f147.png"/>
+          <p:cNvPr id="3" name="Picture 2" descr="f6d64a8230004c8a.png"/>
           <p:cNvPicPr>
             <a:picLocks noChangeAspect="1"/>
           </p:cNvPicPr>
@@ -3952,8 +4267,8 @@
         </p:blipFill>
         <p:spPr>
           <a:xfrm>
-            <a:off x="1372826" y="1097280"/>
-            <a:ext cx="6398348" cy="5303520"/>
+            <a:off x="457200" y="2836709"/>
+            <a:ext cx="8229600" cy="1824662"/>
           </a:xfrm>
           <a:prstGeom prst="rect">
             <a:avLst/>
@@ -4044,7 +4359,22 @@
                   <a:srgbClr val="22282E"/>
                 </a:solidFill>
               </a:rPr>
-              <a:t>•  Comprender la dimensión física del Red Team: cómo un atacante entra a un edificio, elude controles de acceso, clona credenciales, coloca dispositivos y usa ingeniería social presencial para lograr un…</a:t>
+              <a:t>•  Evaluar de forma autorizada cómo el acceso físico, los accesorios USB y los dispositivos compactos de red pueden atravesar o poner a prueba controles técnicos y humanos. La clase desarrolla dos…</a:t>
+            </a:r>
+          </a:p>
+          <a:p>
+            <a:pPr>
+              <a:spcAft>
+                <a:spcPts val="600"/>
+              </a:spcAft>
+            </a:pPr>
+            <a:r>
+              <a:rPr sz="1500">
+                <a:solidFill>
+                  <a:srgbClr val="22282E"/>
+                </a:solidFill>
+              </a:rPr>
+              <a:t>•  El propósito no es demostrar que un producto «hackea» por sí solo. Es construir una cadena causal verificable: qué interfaz presentó, qué aceptó el sistema, qué conducta ocurrió, qué telemetría…</a:t>
             </a:r>
           </a:p>
         </p:txBody>
@@ -4148,67 +4478,82 @@
                   <a:srgbClr val="22282E"/>
                 </a:solidFill>
               </a:rPr>
-              <a:t>•  Planificar un ejercicio físico con reconocimiento y pretexto.</a:t>
-            </a:r>
-          </a:p>
-          <a:p>
-            <a:pPr>
-              <a:spcAft>
-                <a:spcPts val="600"/>
-              </a:spcAft>
-            </a:pPr>
-            <a:r>
-              <a:rPr sz="1500">
-                <a:solidFill>
-                  <a:srgbClr val="22282E"/>
-                </a:solidFill>
-              </a:rPr>
-              <a:t>•  Explicar técnicas de bypass de accesos (tailgating, clonado RFID, LPE física).</a:t>
-            </a:r>
-          </a:p>
-          <a:p>
-            <a:pPr>
-              <a:spcAft>
-                <a:spcPts val="600"/>
-              </a:spcAft>
-            </a:pPr>
-            <a:r>
-              <a:rPr sz="1500">
-                <a:solidFill>
-                  <a:srgbClr val="22282E"/>
-                </a:solidFill>
-              </a:rPr>
-              <a:t>•  Describir dispositivos de implante (dropbox, keyloggers, HID injection).</a:t>
-            </a:r>
-          </a:p>
-          <a:p>
-            <a:pPr>
-              <a:spcAft>
-                <a:spcPts val="600"/>
-              </a:spcAft>
-            </a:pPr>
-            <a:r>
-              <a:rPr sz="1500">
-                <a:solidFill>
-                  <a:srgbClr val="22282E"/>
-                </a:solidFill>
-              </a:rPr>
-              <a:t>•  Redactar un "get-out-of-jail-free letter" y las RoE físicas.</a:t>
-            </a:r>
-          </a:p>
-          <a:p>
-            <a:pPr>
-              <a:spcAft>
-                <a:spcPts val="600"/>
-              </a:spcAft>
-            </a:pPr>
-            <a:r>
-              <a:rPr sz="1500">
-                <a:solidFill>
-                  <a:srgbClr val="22282E"/>
-                </a:solidFill>
-              </a:rPr>
-              <a:t>•  Integrar el acceso físico con la operación de red.</a:t>
+              <a:t>•  Delimitar una prueba física mediante autorización, reglas de compromiso, zonas, horarios y condiciones de parada.</a:t>
+            </a:r>
+          </a:p>
+          <a:p>
+            <a:pPr>
+              <a:spcAft>
+                <a:spcPts val="600"/>
+              </a:spcAft>
+            </a:pPr>
+            <a:r>
+              <a:rPr sz="1500">
+                <a:solidFill>
+                  <a:srgbClr val="22282E"/>
+                </a:solidFill>
+              </a:rPr>
+              <a:t>•  Distinguir un cable normal, un dispositivo USB simple y uno compuesto, y explicar enumeración, interfaces HID, almacenamiento, red y serie.</a:t>
+            </a:r>
+          </a:p>
+          <a:p>
+            <a:pPr>
+              <a:spcAft>
+                <a:spcPts val="600"/>
+              </a:spcAft>
+            </a:pPr>
+            <a:r>
+              <a:rPr sz="1500">
+                <a:solidFill>
+                  <a:srgbClr val="22282E"/>
+                </a:solidFill>
+              </a:rPr>
+              <a:t>•  Comparar O.MG Cable, USB Rubber Ducky, Bash Bunny, placas con USB nativo y Cynthion sin atribuir capacidades de un modelo a otro.</a:t>
+            </a:r>
+          </a:p>
+          <a:p>
+            <a:pPr>
+              <a:spcAft>
+                <a:spcPts val="600"/>
+              </a:spcAft>
+            </a:pPr>
+            <a:r>
+              <a:rPr sz="1500">
+                <a:solidFill>
+                  <a:srgbClr val="22282E"/>
+                </a:solidFill>
+              </a:rPr>
+              <a:t>•  Preparar y restaurar un dispositivo de laboratorio sin dejar credenciales, cargas ni datos de la organización.</a:t>
+            </a:r>
+          </a:p>
+          <a:p>
+            <a:pPr>
+              <a:spcAft>
+                <a:spcPts val="600"/>
+              </a:spcAft>
+            </a:pPr>
+            <a:r>
+              <a:rPr sz="1500">
+                <a:solidFill>
+                  <a:srgbClr val="22282E"/>
+                </a:solidFill>
+              </a:rPr>
+              <a:t>•  Ejecutar una demostración HID inocua y medir conexión, conducta y efecto sin abrir shells ni establecer C2.</a:t>
+            </a:r>
+          </a:p>
+          <a:p>
+            <a:pPr>
+              <a:spcAft>
+                <a:spcPts val="600"/>
+              </a:spcAft>
+            </a:pPr>
+            <a:r>
+              <a:rPr sz="1500">
+                <a:solidFill>
+                  <a:srgbClr val="22282E"/>
+                </a:solidFill>
+              </a:rPr>
+              <a:t>•  Observar evidencia de host y red, diferenciando conexión, conducta sospechosa y atribución a un producto.</a:t>
             </a:r>
           </a:p>
         </p:txBody>
@@ -4297,97 +4642,97 @@
                   <a:srgbClr val="22282E"/>
                 </a:solidFill>
               </a:rPr>
-              <a:t>•  1 — Reconocimiento físico</a:t>
-            </a:r>
-          </a:p>
-          <a:p>
-            <a:pPr>
-              <a:spcAft>
-                <a:spcPts val="600"/>
-              </a:spcAft>
-            </a:pPr>
-            <a:r>
-              <a:rPr sz="1500">
-                <a:solidFill>
-                  <a:srgbClr val="22282E"/>
-                </a:solidFill>
-              </a:rPr>
-              <a:t>•  2 — Pretexto presencial</a:t>
-            </a:r>
-          </a:p>
-          <a:p>
-            <a:pPr>
-              <a:spcAft>
-                <a:spcPts val="600"/>
-              </a:spcAft>
-            </a:pPr>
-            <a:r>
-              <a:rPr sz="1500">
-                <a:solidFill>
-                  <a:srgbClr val="22282E"/>
-                </a:solidFill>
-              </a:rPr>
-              <a:t>•  3 — Bypass de accesos</a:t>
-            </a:r>
-          </a:p>
-          <a:p>
-            <a:pPr>
-              <a:spcAft>
-                <a:spcPts val="600"/>
-              </a:spcAft>
-            </a:pPr>
-            <a:r>
-              <a:rPr sz="1500">
-                <a:solidFill>
-                  <a:srgbClr val="22282E"/>
-                </a:solidFill>
-              </a:rPr>
-              <a:t>•  4 — Clonado de credenciales</a:t>
-            </a:r>
-          </a:p>
-          <a:p>
-            <a:pPr>
-              <a:spcAft>
-                <a:spcPts val="600"/>
-              </a:spcAft>
-            </a:pPr>
-            <a:r>
-              <a:rPr sz="1500">
-                <a:solidFill>
-                  <a:srgbClr val="22282E"/>
-                </a:solidFill>
-              </a:rPr>
-              <a:t>•  5 — Dispositivos de implante</a:t>
-            </a:r>
-          </a:p>
-          <a:p>
-            <a:pPr>
-              <a:spcAft>
-                <a:spcPts val="600"/>
-              </a:spcAft>
-            </a:pPr>
-            <a:r>
-              <a:rPr sz="1500">
-                <a:solidFill>
-                  <a:srgbClr val="22282E"/>
-                </a:solidFill>
-              </a:rPr>
-              <a:t>•  6 — Marco legal</a:t>
-            </a:r>
-          </a:p>
-          <a:p>
-            <a:pPr>
-              <a:spcAft>
-                <a:spcPts val="600"/>
-              </a:spcAft>
-            </a:pPr>
-            <a:r>
-              <a:rPr sz="1500">
-                <a:solidFill>
-                  <a:srgbClr val="22282E"/>
-                </a:solidFill>
-              </a:rPr>
-              <a:t>•  7 — Puente físico→red</a:t>
+              <a:t>•  1 — Alcance físico y seguridad</a:t>
+            </a:r>
+          </a:p>
+          <a:p>
+            <a:pPr>
+              <a:spcAft>
+                <a:spcPts val="600"/>
+              </a:spcAft>
+            </a:pPr>
+            <a:r>
+              <a:rPr sz="1500">
+                <a:solidFill>
+                  <a:srgbClr val="22282E"/>
+                </a:solidFill>
+              </a:rPr>
+              <a:t>•  2 — Enumeración USB</a:t>
+            </a:r>
+          </a:p>
+          <a:p>
+            <a:pPr>
+              <a:spcAft>
+                <a:spcPts val="600"/>
+              </a:spcAft>
+            </a:pPr>
+            <a:r>
+              <a:rPr sz="1500">
+                <a:solidFill>
+                  <a:srgbClr val="22282E"/>
+                </a:solidFill>
+              </a:rPr>
+              <a:t>•  3 — HID y automatización</a:t>
+            </a:r>
+          </a:p>
+          <a:p>
+            <a:pPr>
+              <a:spcAft>
+                <a:spcPts val="600"/>
+              </a:spcAft>
+            </a:pPr>
+            <a:r>
+              <a:rPr sz="1500">
+                <a:solidFill>
+                  <a:srgbClr val="22282E"/>
+                </a:solidFill>
+              </a:rPr>
+              <a:t>•  4 — Dispositivos compuestos</a:t>
+            </a:r>
+          </a:p>
+          <a:p>
+            <a:pPr>
+              <a:spcAft>
+                <a:spcPts val="600"/>
+              </a:spcAft>
+            </a:pPr>
+            <a:r>
+              <a:rPr sz="1500">
+                <a:solidFill>
+                  <a:srgbClr val="22282E"/>
+                </a:solidFill>
+              </a:rPr>
+              <a:t>•  5 — Cables y accesorios alterados</a:t>
+            </a:r>
+          </a:p>
+          <a:p>
+            <a:pPr>
+              <a:spcAft>
+                <a:spcPts val="600"/>
+              </a:spcAft>
+            </a:pPr>
+            <a:r>
+              <a:rPr sz="1500">
+                <a:solidFill>
+                  <a:srgbClr val="22282E"/>
+                </a:solidFill>
+              </a:rPr>
+              <a:t>•  6 — Instrumentación USB</a:t>
+            </a:r>
+          </a:p>
+          <a:p>
+            <a:pPr>
+              <a:spcAft>
+                <a:spcPts val="600"/>
+              </a:spcAft>
+            </a:pPr>
+            <a:r>
+              <a:rPr sz="1500">
+                <a:solidFill>
+                  <a:srgbClr val="22282E"/>
+                </a:solidFill>
+              </a:rPr>
+              <a:t>•  7 — Dispositivos compactos de red</a:t>
             </a:r>
           </a:p>
         </p:txBody>
@@ -4476,82 +4821,97 @@
                   <a:srgbClr val="22282E"/>
                 </a:solidFill>
               </a:rPr>
-              <a:t>•  Una evaluación física no se autoriza solo con una dirección. Las reglas deben identificar edificios y zonas excluidas, horarios, técnicas permitidas, personas que no pueden ser involucradas…</a:t>
-            </a:r>
-          </a:p>
-          <a:p>
-            <a:pPr>
-              <a:spcAft>
-                <a:spcPts val="600"/>
-              </a:spcAft>
-            </a:pPr>
-            <a:r>
-              <a:rPr sz="1500">
-                <a:solidFill>
-                  <a:srgbClr val="22282E"/>
-                </a:solidFill>
-              </a:rPr>
-              <a:t>•  El reconocimiento se limita a información necesaria para probar controles. Registrar matrículas, rostros o rutinas puede crear datos personales que la organización no necesita. La evidencia debe…</a:t>
-            </a:r>
-          </a:p>
-          <a:p>
-            <a:pPr>
-              <a:spcAft>
-                <a:spcPts val="600"/>
-              </a:spcAft>
-            </a:pPr>
-            <a:r>
-              <a:rPr sz="1500">
-                <a:solidFill>
-                  <a:srgbClr val="22282E"/>
-                </a:solidFill>
-              </a:rPr>
-              <a:t>•  Una tarjeta no es todo el sistema de acceso. Importan enrolamiento, tecnología, lector, controlador, puerta, anti-passback, vigilancia y conducta del personal. La posibilidad de leer o copiar un…</a:t>
-            </a:r>
-          </a:p>
-          <a:p>
-            <a:pPr>
-              <a:spcAft>
-                <a:spcPts val="600"/>
-              </a:spcAft>
-            </a:pPr>
-            <a:r>
-              <a:rPr sz="1500">
-                <a:solidFill>
-                  <a:srgbClr val="22282E"/>
-                </a:solidFill>
-              </a:rPr>
-              <a:t>•  Igualmente, un dispositivo USB que declara ser teclado no obtiene privilegios automáticamente. Intervienen bloqueo de pantalla, control de dispositivos, privilegios de la sesión, allowlisting y EDR.…</a:t>
-            </a:r>
-          </a:p>
-          <a:p>
-            <a:pPr>
-              <a:spcAft>
-                <a:spcPts val="600"/>
-              </a:spcAft>
-            </a:pPr>
-            <a:r>
-              <a:rPr sz="1500">
-                <a:solidFill>
-                  <a:srgbClr val="22282E"/>
-                </a:solidFill>
-              </a:rPr>
-              <a:t>•  El objetivo se valida con marcadores inocuos: alcanzar una zona acordada, presentar una tarjeta de prueba, conectar a una VLAN preparada o fotografiar un token puesto por la white cell. No se fuerza…</a:t>
-            </a:r>
-          </a:p>
-          <a:p>
-            <a:pPr>
-              <a:spcAft>
-                <a:spcPts val="600"/>
-              </a:spcAft>
-            </a:pPr>
-            <a:r>
-              <a:rPr sz="1500">
-                <a:solidFill>
-                  <a:srgbClr val="22282E"/>
-                </a:solidFill>
-              </a:rPr>
-              <a:t>•  Al terminar se contabilizan dispositivos, se retiran implantes de prueba, se revocan credenciales temporales y se informa cualquier debilidad que pueda causar un riesgo inmediato. El hallazgo explica…</a:t>
+              <a:t>•  La autorización general para «hacer pentest» no basta para acceder a edificios, conectar hardware o involucrar personas. Las reglas de compromiso deben nombrar sedes y zonas, fechas y ventanas…</a:t>
+            </a:r>
+          </a:p>
+          <a:p>
+            <a:pPr>
+              <a:spcAft>
+                <a:spcPts val="600"/>
+              </a:spcAft>
+            </a:pPr>
+            <a:r>
+              <a:rPr sz="1500">
+                <a:solidFill>
+                  <a:srgbClr val="22282E"/>
+                </a:solidFill>
+              </a:rPr>
+              <a:t>•  Esta clase reutiliza el método completo de la Clase 025 — Ética, legalidad, alcance y divulgación responsable. En una prueba física se agregan riesgos que allí no siempre aparecen: lesiones, bloqueo…</a:t>
+            </a:r>
+          </a:p>
+          <a:p>
+            <a:pPr>
+              <a:spcAft>
+                <a:spcPts val="600"/>
+              </a:spcAft>
+            </a:pPr>
+            <a:r>
+              <a:rPr sz="1500">
+                <a:solidFill>
+                  <a:srgbClr val="22282E"/>
+                </a:solidFill>
+              </a:rPr>
+              <a:t>•  Al insertar un dispositivo, el host detecta presencia, restablece el bus, asigna una dirección y solicita descriptores. Esos datos anuncian fabricante y producto, pero, sobre todo, una o más…</a:t>
+            </a:r>
+          </a:p>
+          <a:p>
+            <a:pPr>
+              <a:spcAft>
+                <a:spcPts val="600"/>
+              </a:spcAft>
+            </a:pPr>
+            <a:r>
+              <a:rPr sz="1500">
+                <a:solidFill>
+                  <a:srgbClr val="22282E"/>
+                </a:solidFill>
+              </a:rPr>
+              <a:t>•  Los valores VID, PID, nombre y número de serie ayudan a inventariar, pero son afirmaciones del dispositivo, no identidad criptográfica. Herramientas de emulación pueden cambiarlos. El puerto físico…</a:t>
+            </a:r>
+          </a:p>
+          <a:p>
+            <a:pPr>
+              <a:spcAft>
+                <a:spcPts val="600"/>
+              </a:spcAft>
+            </a:pPr>
+            <a:r>
+              <a:rPr sz="1500">
+                <a:solidFill>
+                  <a:srgbClr val="22282E"/>
+                </a:solidFill>
+              </a:rPr>
+              <a:t>•  El diagrama se lee de izquierda a derecha. La conexión conduce a una declaración de capacidades; cada interfaz abre una ruta distinta y deja evidencia diferente. Solo al correlacionar esas rutas…</a:t>
+            </a:r>
+          </a:p>
+          <a:p>
+            <a:pPr>
+              <a:spcAft>
+                <a:spcPts val="600"/>
+              </a:spcAft>
+            </a:pPr>
+            <a:r>
+              <a:rPr sz="1500">
+                <a:solidFill>
+                  <a:srgbClr val="22282E"/>
+                </a:solidFill>
+              </a:rPr>
+              <a:t>•  USB Rubber Ducky. En el modelo actual, DuckyScript 3 controla modos HID, STORAGE, la combinación de ambos u OFF. Su función pedagógica principal es estudiar automatización de teclado, tiempos de…</a:t>
+            </a:r>
+          </a:p>
+          <a:p>
+            <a:pPr>
+              <a:spcAft>
+                <a:spcPts val="600"/>
+              </a:spcAft>
+            </a:pPr>
+            <a:r>
+              <a:rPr sz="1500">
+                <a:solidFill>
+                  <a:srgbClr val="22282E"/>
+                </a:solidFill>
+              </a:rPr>
+              <a:t>•  Bash Bunny. Es un sistema Linux embebido capaz de declarar combinaciones de HID, almacenamiento, serie y adaptadores Ethernet ECM/RNDIS según firmware y modo. Eso lo hace apropiado para estudiar…</a:t>
             </a:r>
           </a:p>
         </p:txBody>
@@ -4640,82 +5000,97 @@
                   <a:srgbClr val="22282E"/>
                 </a:solidFill>
               </a:rPr>
-              <a:t>•  Tailgating / piggybacking: entrar detrás de un empleado autorizado. Característica: explota la cortesía humana, no un fallo técnico.</a:t>
-            </a:r>
-          </a:p>
-          <a:p>
-            <a:pPr>
-              <a:spcAft>
-                <a:spcPts val="600"/>
-              </a:spcAft>
-            </a:pPr>
-            <a:r>
-              <a:rPr sz="1500">
-                <a:solidFill>
-                  <a:srgbClr val="22282E"/>
-                </a:solidFill>
-              </a:rPr>
-              <a:t>•  Clonado RFID: reproducción de datos de credenciales compatibles y débiles. Característica: no toda tarjeta de 125 kHz o 13,56 MHz es clonable; protocolo, claves y backend determinan el riesgo.</a:t>
-            </a:r>
-          </a:p>
-          <a:p>
-            <a:pPr>
-              <a:spcAft>
-                <a:spcPts val="600"/>
-              </a:spcAft>
-            </a:pPr>
-            <a:r>
-              <a:rPr sz="1500">
-                <a:solidFill>
-                  <a:srgbClr val="22282E"/>
-                </a:solidFill>
-              </a:rPr>
-              <a:t>•  Dropbox: dispositivo (ej. una mini-PC) dejado en la red interna con conectividad C2. Característica: convierte el acceso físico en foothold remoto.</a:t>
-            </a:r>
-          </a:p>
-          <a:p>
-            <a:pPr>
-              <a:spcAft>
-                <a:spcPts val="600"/>
-              </a:spcAft>
-            </a:pPr>
-            <a:r>
-              <a:rPr sz="1500">
-                <a:solidFill>
-                  <a:srgbClr val="22282E"/>
-                </a:solidFill>
-              </a:rPr>
-              <a:t>•  HID injection: dispositivo que se hace pasar por teclado (Rubber Ducky) para ejecutar comandos. Característica: rápido y difícil de bloquear por USB storage policies.</a:t>
-            </a:r>
-          </a:p>
-          <a:p>
-            <a:pPr>
-              <a:spcAft>
-                <a:spcPts val="600"/>
-              </a:spcAft>
-            </a:pPr>
-            <a:r>
-              <a:rPr sz="1500">
-                <a:solidFill>
-                  <a:srgbClr val="22282E"/>
-                </a:solidFill>
-              </a:rPr>
-              <a:t>•  Carta de autorización de emergencia: documento firmado y verificable que acredita alcance y contactos si el operador es interceptado. Característica: no otorga inmunidad ni sustituye el cumplimiento…</a:t>
-            </a:r>
-          </a:p>
-          <a:p>
-            <a:pPr>
-              <a:spcAft>
-                <a:spcPts val="600"/>
-              </a:spcAft>
-            </a:pPr>
-            <a:r>
-              <a:rPr sz="1500">
-                <a:solidFill>
-                  <a:srgbClr val="22282E"/>
-                </a:solidFill>
-              </a:rPr>
-              <a:t>•  RoE físicas: reglas de qué edificios, horarios y métodos están permitidos. Característica: delimitan el ejercicio físico.</a:t>
+              <a:t>•  Enumeración USB: negociación por la que el host conoce descriptores y configura el dispositivo. Ocurre antes de que la aplicación use la interfaz.</a:t>
+            </a:r>
+          </a:p>
+          <a:p>
+            <a:pPr>
+              <a:spcAft>
+                <a:spcPts val="600"/>
+              </a:spcAft>
+            </a:pPr>
+            <a:r>
+              <a:rPr sz="1500">
+                <a:solidFill>
+                  <a:srgbClr val="22282E"/>
+                </a:solidFill>
+              </a:rPr>
+              <a:t>•  HID: clase USB para interfaces humanas. Ser HID no prueba automatización; teclados legítimos pertenecen a la misma clase.</a:t>
+            </a:r>
+          </a:p>
+          <a:p>
+            <a:pPr>
+              <a:spcAft>
+                <a:spcPts val="600"/>
+              </a:spcAft>
+            </a:pPr>
+            <a:r>
+              <a:rPr sz="1500">
+                <a:solidFill>
+                  <a:srgbClr val="22282E"/>
+                </a:solidFill>
+              </a:rPr>
+              <a:t>•  Dispositivo compuesto: dispositivo con varias interfaces, por ejemplo HID más almacenamiento. Debe evaluarse por el conjunto, no por una función visible.</a:t>
+            </a:r>
+          </a:p>
+          <a:p>
+            <a:pPr>
+              <a:spcAft>
+                <a:spcPts val="600"/>
+              </a:spcAft>
+            </a:pPr>
+            <a:r>
+              <a:rPr sz="1500">
+                <a:solidFill>
+                  <a:srgbClr val="22282E"/>
+                </a:solidFill>
+              </a:rPr>
+              <a:t>•  DuckyScript: lenguaje de automatización compatible con varios productos Hak5, con comandos que varían por dispositivo y versión.</a:t>
+            </a:r>
+          </a:p>
+          <a:p>
+            <a:pPr>
+              <a:spcAft>
+                <a:spcPts val="600"/>
+              </a:spcAft>
+            </a:pPr>
+            <a:r>
+              <a:rPr sz="1500">
+                <a:solidFill>
+                  <a:srgbClr val="22282E"/>
+                </a:solidFill>
+              </a:rPr>
+              <a:t>•  Analizador de protocolo: instrumento que observa transacciones del bus. No equivale a un endpoint ni decide por sí solo si una acción es maliciosa.</a:t>
+            </a:r>
+          </a:p>
+          <a:p>
+            <a:pPr>
+              <a:spcAft>
+                <a:spcPts val="600"/>
+              </a:spcAft>
+            </a:pPr>
+            <a:r>
+              <a:rPr sz="1500">
+                <a:solidFill>
+                  <a:srgbClr val="22282E"/>
+                </a:solidFill>
+              </a:rPr>
+              <a:t>•  Dropbox: equipo inventariado colocado temporalmente para probar acceso a red. Debe tener propietario, tiempo de retiro y método de contención.</a:t>
+            </a:r>
+          </a:p>
+          <a:p>
+            <a:pPr>
+              <a:spcAft>
+                <a:spcPts val="600"/>
+              </a:spcAft>
+            </a:pPr>
+            <a:r>
+              <a:rPr sz="1500">
+                <a:solidFill>
+                  <a:srgbClr val="22282E"/>
+                </a:solidFill>
+              </a:rPr>
+              <a:t>•  TAP: punto de acceso de prueba que replica tráfico para observación. Su valor es medible por cobertura y pérdida, no por invisibilidad prometida.</a:t>
             </a:r>
           </a:p>
         </p:txBody>
@@ -4804,97 +5179,97 @@
                   <a:srgbClr val="22282E"/>
                 </a:solidFill>
               </a:rPr>
-              <a:t>•  Alcance físico: espacios, horarios, personas y métodos incluidos expresamente.</a:t>
-            </a:r>
-          </a:p>
-          <a:p>
-            <a:pPr>
-              <a:spcAft>
-                <a:spcPts val="600"/>
-              </a:spcAft>
-            </a:pPr>
-            <a:r>
-              <a:rPr sz="1500">
-                <a:solidFill>
-                  <a:srgbClr val="22282E"/>
-                </a:solidFill>
-              </a:rPr>
-              <a:t>•  Zona restringida: área con controles adicionales por sensibilidad o seguridad.</a:t>
-            </a:r>
-          </a:p>
-          <a:p>
-            <a:pPr>
-              <a:spcAft>
-                <a:spcPts val="600"/>
-              </a:spcAft>
-            </a:pPr>
-            <a:r>
-              <a:rPr sz="1500">
-                <a:solidFill>
-                  <a:srgbClr val="22282E"/>
-                </a:solidFill>
-              </a:rPr>
-              <a:t>•  Tailgating: entrada no autorizada aprovechando la apertura de una persona autorizada.</a:t>
-            </a:r>
-          </a:p>
-          <a:p>
-            <a:pPr>
-              <a:spcAft>
-                <a:spcPts val="600"/>
-              </a:spcAft>
-            </a:pPr>
-            <a:r>
-              <a:rPr sz="1500">
-                <a:solidFill>
-                  <a:srgbClr val="22282E"/>
-                </a:solidFill>
-              </a:rPr>
-              <a:t>•  Piggybacking: acceso con conocimiento o cooperación de quien habilita el paso; el uso varía entre organizaciones.</a:t>
-            </a:r>
-          </a:p>
-          <a:p>
-            <a:pPr>
-              <a:spcAft>
-                <a:spcPts val="600"/>
-              </a:spcAft>
-            </a:pPr>
-            <a:r>
-              <a:rPr sz="1500">
-                <a:solidFill>
-                  <a:srgbClr val="22282E"/>
-                </a:solidFill>
-              </a:rPr>
-              <a:t>•  Badge: credencial física o móvil presentada a un sistema de control de acceso.</a:t>
-            </a:r>
-          </a:p>
-          <a:p>
-            <a:pPr>
-              <a:spcAft>
-                <a:spcPts val="600"/>
-              </a:spcAft>
-            </a:pPr>
-            <a:r>
-              <a:rPr sz="1500">
-                <a:solidFill>
-                  <a:srgbClr val="22282E"/>
-                </a:solidFill>
-              </a:rPr>
-              <a:t>•  RFID/NFC: familias de tecnologías de radio; frecuencia por sí sola no determina seguridad.</a:t>
-            </a:r>
-          </a:p>
-          <a:p>
-            <a:pPr>
-              <a:spcAft>
-                <a:spcPts val="600"/>
-              </a:spcAft>
-            </a:pPr>
-            <a:r>
-              <a:rPr sz="1500">
-                <a:solidFill>
-                  <a:srgbClr val="22282E"/>
-                </a:solidFill>
-              </a:rPr>
-              <a:t>•  HID: clase de dispositivo de interfaz humana, como teclado o ratón.</a:t>
+              <a:t>•  Término — Definición útil</a:t>
+            </a:r>
+          </a:p>
+          <a:p>
+            <a:pPr>
+              <a:spcAft>
+                <a:spcPts val="600"/>
+              </a:spcAft>
+            </a:pPr>
+            <a:r>
+              <a:rPr sz="1500">
+                <a:solidFill>
+                  <a:srgbClr val="22282E"/>
+                </a:solidFill>
+              </a:rPr>
+              <a:t>•  VID/PID — Valores declarados por el dispositivo para fabricante/producto; útiles para inventario, falsificables.</a:t>
+            </a:r>
+          </a:p>
+          <a:p>
+            <a:pPr>
+              <a:spcAft>
+                <a:spcPts val="600"/>
+              </a:spcAft>
+            </a:pPr>
+            <a:r>
+              <a:rPr sz="1500">
+                <a:solidFill>
+                  <a:srgbClr val="22282E"/>
+                </a:solidFill>
+              </a:rPr>
+              <a:t>•  Descriptor — Estructura USB que anuncia configuración, interfaces y endpoints.</a:t>
+            </a:r>
+          </a:p>
+          <a:p>
+            <a:pPr>
+              <a:spcAft>
+                <a:spcPts val="600"/>
+              </a:spcAft>
+            </a:pPr>
+            <a:r>
+              <a:rPr sz="1500">
+                <a:solidFill>
+                  <a:srgbClr val="22282E"/>
+                </a:solidFill>
+              </a:rPr>
+              <a:t>•  Interfaz — Función lógica dentro de un dispositivo USB.</a:t>
+            </a:r>
+          </a:p>
+          <a:p>
+            <a:pPr>
+              <a:spcAft>
+                <a:spcPts val="600"/>
+              </a:spcAft>
+            </a:pPr>
+            <a:r>
+              <a:rPr sz="1500">
+                <a:solidFill>
+                  <a:srgbClr val="22282E"/>
+                </a:solidFill>
+              </a:rPr>
+              <a:t>•  ECM/RNDIS — Formas de presentar un adaptador Ethernet por USB en diferentes sistemas.</a:t>
+            </a:r>
+          </a:p>
+          <a:p>
+            <a:pPr>
+              <a:spcAft>
+                <a:spcPts val="600"/>
+              </a:spcAft>
+            </a:pPr>
+            <a:r>
+              <a:rPr sz="1500">
+                <a:solidFill>
+                  <a:srgbClr val="22282E"/>
+                </a:solidFill>
+              </a:rPr>
+              <a:t>•  Allowlist — Política que autoriza solo identidades, interfaces o puertos esperados.</a:t>
+            </a:r>
+          </a:p>
+          <a:p>
+            <a:pPr>
+              <a:spcAft>
+                <a:spcPts val="600"/>
+              </a:spcAft>
+            </a:pPr>
+            <a:r>
+              <a:rPr sz="1500">
+                <a:solidFill>
+                  <a:srgbClr val="22282E"/>
+                </a:solidFill>
+              </a:rPr>
+              <a:t>•  Arming mode — Estado de administración separado de la ejecución en algunos equipos.</a:t>
             </a:r>
           </a:p>
         </p:txBody>
@@ -4983,52 +5358,52 @@
                   <a:srgbClr val="22282E"/>
                 </a:solidFill>
               </a:rPr>
-              <a:t>•  Herramientas de estudio: Proxmark3/Flipper Zero (RFID), Rubber Ducky/O.MG cable (HID), lockpicks (donde sea legal), una mini-PC como dropbox.</a:t>
-            </a:r>
-          </a:p>
-          <a:p>
-            <a:pPr>
-              <a:spcAft>
-                <a:spcPts val="600"/>
-              </a:spcAft>
-            </a:pPr>
-            <a:r>
-              <a:rPr sz="1500">
-                <a:solidFill>
-                  <a:srgbClr val="22282E"/>
-                </a:solidFill>
-              </a:rPr>
-              <a:t>•  Cámara y libreta para el reconocimiento; ropa/props para el pretexto.</a:t>
-            </a:r>
-          </a:p>
-          <a:p>
-            <a:pPr>
-              <a:spcAft>
-                <a:spcPts val="600"/>
-              </a:spcAft>
-            </a:pPr>
-            <a:r>
-              <a:rPr sz="1500">
-                <a:solidFill>
-                  <a:srgbClr val="22282E"/>
-                </a:solidFill>
-              </a:rPr>
-              <a:t>•  La carta de autorización firmada y las RoE físicas del engagement.</a:t>
-            </a:r>
-          </a:p>
-          <a:p>
-            <a:pPr>
-              <a:spcAft>
-                <a:spcPts val="600"/>
-              </a:spcAft>
-            </a:pPr>
-            <a:r>
-              <a:rPr sz="1500">
-                <a:solidFill>
-                  <a:srgbClr val="22282E"/>
-                </a:solidFill>
-              </a:rPr>
-              <a:t>•  Conectividad C2 preparada para el dropbox (Clases 164–165).</a:t>
+              <a:t>•  Banco mínimo: portátil de laboratorio sin datos reales, snapshot o imagen recuperable, un teclado normal, una memoria USB y una placa con USB nativo o dispositivo comercial inventariado. Cynthion es…</a:t>
+            </a:r>
+          </a:p>
+          <a:p>
+            <a:pPr>
+              <a:spcAft>
+                <a:spcPts val="600"/>
+              </a:spcAft>
+            </a:pPr>
+            <a:r>
+              <a:rPr sz="1500">
+                <a:solidFill>
+                  <a:srgbClr val="22282E"/>
+                </a:solidFill>
+              </a:rPr>
+              <a:t>•  Topología: dispositivo USB → endpoint de prueba → sensor de host; para red, cliente de prueba → dispositivo intermedio → switch aislado → servicio sintético. No se conecta el banco a la LAN…</a:t>
+            </a:r>
+          </a:p>
+          <a:p>
+            <a:pPr>
+              <a:spcAft>
+                <a:spcPts val="600"/>
+              </a:spcAft>
+            </a:pPr>
+            <a:r>
+              <a:rPr sz="1500">
+                <a:solidFill>
+                  <a:srgbClr val="22282E"/>
+                </a:solidFill>
+              </a:rPr>
+              <a:t>•  Comprobaciones antes de ejecutar:</a:t>
+            </a:r>
+          </a:p>
+          <a:p>
+            <a:pPr>
+              <a:spcAft>
+                <a:spcPts val="600"/>
+              </a:spcAft>
+            </a:pPr>
+            <a:r>
+              <a:rPr sz="1500">
+                <a:solidFill>
+                  <a:srgbClr val="22282E"/>
+                </a:solidFill>
+              </a:rPr>
+              <a:t>•  En USBGuard, una regla como allow with-interface equals { 08:: } significa «solo almacenamiento»: un compuesto que además anuncie HID no coincide. La política debe generarse sobre una VM de prueba…</a:t>
             </a:r>
           </a:p>
         </p:txBody>
@@ -5079,7 +5454,7 @@
                   <a:srgbClr val="0B3D2E"/>
                 </a:solidFill>
               </a:rPr>
-              <a:t>🧪 Laboratorio guiado (entorno propio)</a:t>
+              <a:t>🧪 Laboratorio guiado — HID inocuo y defensa por capas</a:t>
             </a:r>
           </a:p>
         </p:txBody>
@@ -5117,97 +5492,97 @@
                   <a:srgbClr val="22282E"/>
                 </a:solidFill>
               </a:rPr>
-              <a:t>•  Reconocimiento simulado. Sobre un edificio ficticio, documenta accesos, horarios, tipos de badge y puntos ciegos que observarías (ejercicio en papel/mapa).</a:t>
-            </a:r>
-          </a:p>
-          <a:p>
-            <a:pPr>
-              <a:spcAft>
-                <a:spcPts val="600"/>
-              </a:spcAft>
-            </a:pPr>
-            <a:r>
-              <a:rPr sz="1500">
-                <a:solidFill>
-                  <a:srgbClr val="22282E"/>
-                </a:solidFill>
-              </a:rPr>
-              <a:t>•  Diseña el pretexto. Elige uno (técnico de mantenimiento, repartidor) y prepara props y una historia coherente.</a:t>
-            </a:r>
-          </a:p>
-          <a:p>
-            <a:pPr>
-              <a:spcAft>
-                <a:spcPts val="600"/>
-              </a:spcAft>
-            </a:pPr>
-            <a:r>
-              <a:rPr sz="1500">
-                <a:solidFill>
-                  <a:srgbClr val="22282E"/>
-                </a:solidFill>
-              </a:rPr>
-              <a:t>•  Clonado RFID (tu propia tarjeta). Con un lector, lee y clona una tarjeta que te pertenezca para entender el proceso; nunca la de un tercero.</a:t>
-            </a:r>
-          </a:p>
-          <a:p>
-            <a:pPr>
-              <a:spcAft>
-                <a:spcPts val="600"/>
-              </a:spcAft>
-            </a:pPr>
-            <a:r>
-              <a:rPr sz="1500">
-                <a:solidFill>
-                  <a:srgbClr val="22282E"/>
-                </a:solidFill>
-              </a:rPr>
-              <a:t>•  HID injection (tu equipo). Programa un Rubber Ducky para abrir una shell C2 en tu máquina de laboratorio y mide cuánto tarda.</a:t>
-            </a:r>
-          </a:p>
-          <a:p>
-            <a:pPr>
-              <a:spcAft>
-                <a:spcPts val="600"/>
-              </a:spcAft>
-            </a:pPr>
-            <a:r>
-              <a:rPr sz="1500">
-                <a:solidFill>
-                  <a:srgbClr val="22282E"/>
-                </a:solidFill>
-              </a:rPr>
-              <a:t>•  Prepara un dropbox. Configura una mini-PC/VM que, al conectarse a la red del lab, establezca C2 saliente por el redirector.</a:t>
-            </a:r>
-          </a:p>
-          <a:p>
-            <a:pPr>
-              <a:spcAft>
-                <a:spcPts val="600"/>
-              </a:spcAft>
-            </a:pPr>
-            <a:r>
-              <a:rPr sz="1500">
-                <a:solidFill>
-                  <a:srgbClr val="22282E"/>
-                </a:solidFill>
-              </a:rPr>
-              <a:t>•  Documenta la carta de autorización. Redacta una plantilla de get-out-of-jail letter con los campos esenciales.</a:t>
-            </a:r>
-          </a:p>
-          <a:p>
-            <a:pPr>
-              <a:spcAft>
-                <a:spcPts val="600"/>
-              </a:spcAft>
-            </a:pPr>
-            <a:r>
-              <a:rPr sz="1500">
-                <a:solidFill>
-                  <a:srgbClr val="22282E"/>
-                </a:solidFill>
-              </a:rPr>
-              <a:t>•  Puente a la red. Explica cómo el dropbox o el HID te dan el foothold que continuaría en las técnicas de AD ya vistas.</a:t>
+              <a:t>•  Objetivo. Observar enumeración y automatización sin abrir una terminal, descargar contenido, elevar privilegios ni comunicarse por red.</a:t>
+            </a:r>
+          </a:p>
+          <a:p>
+            <a:pPr>
+              <a:spcAft>
+                <a:spcPts val="600"/>
+              </a:spcAft>
+            </a:pPr>
+            <a:r>
+              <a:rPr sz="1500">
+                <a:solidFill>
+                  <a:srgbClr val="22282E"/>
+                </a:solidFill>
+              </a:rPr>
+              <a:t>•  Prerrequisitos. Haber completado la Clase 025; máquina desechable con editor de texto abierto; reloj sincronizado; permisos para revisar logs; dispositivo de laboratorio inventariado. No usar un…</a:t>
+            </a:r>
+          </a:p>
+          <a:p>
+            <a:pPr>
+              <a:spcAft>
+                <a:spcPts val="600"/>
+              </a:spcAft>
+            </a:pPr>
+            <a:r>
+              <a:rPr sz="1500">
+                <a:solidFill>
+                  <a:srgbClr val="22282E"/>
+                </a:solidFill>
+              </a:rPr>
+              <a:t>•  Payload inocuo de referencia (DuckyScript 3):</a:t>
+            </a:r>
+          </a:p>
+          <a:p>
+            <a:pPr>
+              <a:spcAft>
+                <a:spcPts val="600"/>
+              </a:spcAft>
+            </a:pPr>
+            <a:r>
+              <a:rPr sz="1500">
+                <a:solidFill>
+                  <a:srgbClr val="22282E"/>
+                </a:solidFill>
+              </a:rPr>
+              <a:t>•  ATTACKMODE HID presenta teclado; DELAY permite completar enumeración; STRINGLN escribe el marcador y Enter; OFF desactiva la interfaz. En una placa distinta, implementa la misma secuencia y documenta…</a:t>
+            </a:r>
+          </a:p>
+          <a:p>
+            <a:pPr>
+              <a:spcAft>
+                <a:spcPts val="600"/>
+              </a:spcAft>
+            </a:pPr>
+            <a:r>
+              <a:rPr sz="1500">
+                <a:solidFill>
+                  <a:srgbClr val="22282E"/>
+                </a:solidFill>
+              </a:rPr>
+              <a:t>•  Procedimiento reproducible.</a:t>
+            </a:r>
+          </a:p>
+          <a:p>
+            <a:pPr>
+              <a:spcAft>
+                <a:spcPts val="600"/>
+              </a:spcAft>
+            </a:pPr>
+            <a:r>
+              <a:rPr sz="1500">
+                <a:solidFill>
+                  <a:srgbClr val="22282E"/>
+                </a:solidFill>
+              </a:rPr>
+              <a:t>•  Crea una hoja de alcance con host, dispositivo, operador, hora, payload, resultado permitido y condición de parada.</a:t>
+            </a:r>
+          </a:p>
+          <a:p>
+            <a:pPr>
+              <a:spcAft>
+                <a:spcPts val="600"/>
+              </a:spcAft>
+            </a:pPr>
+            <a:r>
+              <a:rPr sz="1500">
+                <a:solidFill>
+                  <a:srgbClr val="22282E"/>
+                </a:solidFill>
+              </a:rPr>
+              <a:t>•  Obtén inventario inicial PnP/lsusb, interfaces de red, rutas y hora. Abre un editor vacío y asegúrate de que no tiene privilegios elevados.</a:t>
             </a:r>
           </a:p>
         </p:txBody>

</xml_diff>